<commit_message>
Add dedicated block/flow/sequence diagrams to every session deck
Match cuda_memtest's per-session diagram density (~2 each), adapted to
memtestG80: host<->device hardware block + program-flow (S0), kernel-launch
flow (S1), memory-scope nesting + host<->device sequence (S2), global-atomic
vs hierarchical-reduction (S3), walking-bit progression + D2D bandwidth (S4),
3-layer call flow + embed lifecycle (S5). Adds arrow/nodeBox helpers to
_deck.js; regenerated all six PPTX (10 new diagram slides).

Co-Authored-By: Claude Opus 4.8 <noreply@anthropic.com>
Claude-Session: https://claude.ai/code/session_01C3af1UXSixHFnU3LeWBAex
</commit_message>
<xml_diff>
--- a/docs/seminar/slides/세션1_스레드모델과_주소매핑.pptx
+++ b/docs/seminar/slides/세션1_스레드모델과_주소매핑.pptx
@@ -16,9 +16,10 @@
     <p:sldId id="264" r:id="rId10"/>
     <p:sldId id="265" r:id="rId11"/>
     <p:sldId id="266" r:id="rId12"/>
+    <p:sldId id="267" r:id="rId13"/>
   </p:sldIdLst>
   <p:notesMasterIdLst>
-    <p:notesMasterId r:id="rId13"/>
+    <p:notesMasterId r:id="rId14"/>
   </p:notesMasterIdLst>
   <p:sldSz cx="12192000" cy="6858000"/>
   <p:notesSz cx="6858000" cy="12192000"/>
@@ -600,7 +601,7 @@
           <a:p>
             <a:r>
               <a:rPr lang="en-US" dirty="0"/>
-              <a:t>네 가지 목표(슬라이드 2)로 돌아가 자가 점검을 유도하세요.</a:t>
+              <a:t>launch = CPU 한 줄 → GPU가 블록을 SM에 분배 → 워프 실행 → 완료. 호스트는 비동기로 리턴한다는 점이 다음 세션들의 복선.</a:t>
             </a:r>
             <a:endParaRPr lang="en-US" dirty="0"/>
           </a:p>
@@ -688,7 +689,7 @@
           <a:p>
             <a:r>
               <a:rPr lang="en-US" dirty="0"/>
-              <a:t/>
+              <a:t>네 가지 목표(슬라이드 2)로 돌아가 자가 점검을 유도하세요.</a:t>
             </a:r>
             <a:endParaRPr lang="en-US" dirty="0"/>
           </a:p>
@@ -712,6 +713,94 @@
             <a:fld id="{F7021451-1387-4CA6-816F-3879F97B5CBC}" type="slidenum">
               <a:rPr lang="en-US"/>
               <a:t>11</a:t>
+            </a:fld>
+            <a:endParaRPr lang="en-US"/>
+          </a:p>
+        </p:txBody>
+      </p:sp>
+    </p:spTree>
+    <p:extLst>
+      <p:ext uri="{BB962C8B-B14F-4D97-AF65-F5344CB8AC3E}">
+        <p14:creationId xmlns:p14="http://schemas.microsoft.com/office/powerpoint/2010/main" val="1024086991"/>
+      </p:ext>
+    </p:extLst>
+  </p:cSld>
+  <p:clrMapOvr>
+    <a:masterClrMapping/>
+  </p:clrMapOvr>
+</p:notes>
+</file>
+
+<file path=ppt/notesSlides/notesSlide12.xml><?xml version="1.0" encoding="utf-8"?>
+<p:notes xmlns:a="http://schemas.openxmlformats.org/drawingml/2006/main" xmlns:r="http://schemas.openxmlformats.org/officeDocument/2006/relationships" xmlns:p="http://schemas.openxmlformats.org/presentationml/2006/main">
+  <p:cSld>
+    <p:spTree>
+      <p:nvGrpSpPr>
+        <p:cNvPr id="1" name=""/>
+        <p:cNvGrpSpPr/>
+        <p:nvPr/>
+      </p:nvGrpSpPr>
+      <p:grpSpPr>
+        <a:xfrm>
+          <a:off x="0" y="0"/>
+          <a:ext cx="0" cy="0"/>
+          <a:chOff x="0" y="0"/>
+          <a:chExt cx="0" cy="0"/>
+        </a:xfrm>
+      </p:grpSpPr>
+      <p:sp>
+        <p:nvSpPr>
+          <p:cNvPr id="2" name="Slide Image Placeholder 1"/>
+          <p:cNvSpPr>
+            <a:spLocks noGrp="1" noRot="1" noChangeAspect="1"/>
+          </p:cNvSpPr>
+          <p:nvPr>
+            <p:ph type="sldImg"/>
+          </p:nvPr>
+        </p:nvSpPr>
+        <p:spPr/>
+      </p:sp>
+      <p:sp>
+        <p:nvSpPr>
+          <p:cNvPr id="3" name="Notes Placeholder 2"/>
+          <p:cNvSpPr>
+            <a:spLocks noGrp="1"/>
+          </p:cNvSpPr>
+          <p:nvPr>
+            <p:ph type="body" idx="1"/>
+          </p:nvPr>
+        </p:nvSpPr>
+        <p:spPr/>
+        <p:txBody>
+          <a:bodyPr/>
+          <a:lstStyle/>
+          <a:p>
+            <a:r>
+              <a:rPr lang="en-US" dirty="0"/>
+              <a:t/>
+            </a:r>
+            <a:endParaRPr lang="en-US" dirty="0"/>
+          </a:p>
+        </p:txBody>
+      </p:sp>
+      <p:sp>
+        <p:nvSpPr>
+          <p:cNvPr id="4" name="Slide Number Placeholder 3"/>
+          <p:cNvSpPr>
+            <a:spLocks noGrp="1"/>
+          </p:cNvSpPr>
+          <p:nvPr>
+            <p:ph type="sldNum" sz="quarter" idx="10"/>
+          </p:nvPr>
+        </p:nvSpPr>
+        <p:spPr/>
+        <p:txBody>
+          <a:bodyPr/>
+          <a:lstStyle/>
+          <a:p>
+            <a:fld id="{F7021451-1387-4CA6-816F-3879F97B5CBC}" type="slidenum">
+              <a:rPr lang="en-US"/>
+              <a:t>12</a:t>
             </a:fld>
             <a:endParaRPr lang="en-US"/>
           </a:p>
@@ -2082,7 +2171,7 @@
             </a:avLst>
           </a:prstGeom>
           <a:solidFill>
-            <a:srgbClr val="E8A33D"/>
+            <a:srgbClr val="3FB8C4"/>
           </a:solidFill>
           <a:ln/>
         </p:spPr>
@@ -2102,7 +2191,7 @@
                 <a:ea typeface="Courier New" pitchFamily="34" charset="-122"/>
                 <a:cs typeface="Courier New" pitchFamily="34" charset="-120"/>
               </a:rPr>
-              <a:t>9</a:t>
+              <a:t>8</a:t>
             </a:r>
             <a:endParaRPr lang="en-US" sz="2200" dirty="0"/>
           </a:p>
@@ -2141,7 +2230,7 @@
                 <a:ea typeface="Malgun Gothic" pitchFamily="34" charset="-122"/>
                 <a:cs typeface="Malgun Gothic" pitchFamily="34" charset="-120"/>
               </a:rPr>
-              <a:t>핵심 정리 &amp; 자주 하는 실수</a:t>
+              <a:t>커널 launch 흐름 · 호출에서 완료까지</a:t>
             </a:r>
             <a:endParaRPr lang="en-US" sz="2900" dirty="0"/>
           </a:p>
@@ -2149,36 +2238,650 @@
       </p:sp>
       <p:sp>
         <p:nvSpPr>
-          <p:cNvPr id="4" name="Shape 2"/>
-          <p:cNvSpPr/>
-          <p:nvPr/>
-        </p:nvSpPr>
-        <p:spPr>
-          <a:xfrm>
-            <a:off x="548640" y="1600200"/>
-            <a:ext cx="5349240" cy="4114800"/>
+          <p:cNvPr id="4" name="Text 2"/>
+          <p:cNvSpPr/>
+          <p:nvPr/>
+        </p:nvSpPr>
+        <p:spPr>
+          <a:xfrm>
+            <a:off x="548640" y="1371600"/>
+            <a:ext cx="11064240" cy="411480"/>
+          </a:xfrm>
+          <a:prstGeom prst="rect">
+            <a:avLst/>
+          </a:prstGeom>
+          <a:noFill/>
+          <a:ln/>
+        </p:spPr>
+        <p:txBody>
+          <a:bodyPr wrap="square" lIns="0" tIns="0" rIns="0" bIns="0" rtlCol="0" anchor="ctr"/>
+          <a:lstStyle/>
+          <a:p>
+            <a:pPr indent="0" marL="0">
+              <a:buNone/>
+            </a:pPr>
+            <a:r>
+              <a:rPr lang="en-US" sz="1450" dirty="0">
+                <a:solidFill>
+                  <a:srgbClr val="9FB0C4"/>
+                </a:solidFill>
+                <a:latin typeface="Malgun Gothic" pitchFamily="34" charset="0"/>
+                <a:ea typeface="Malgun Gothic" pitchFamily="34" charset="-122"/>
+                <a:cs typeface="Malgun Gothic" pitchFamily="34" charset="-120"/>
+              </a:rPr>
+              <a:t>&lt;&lt;&lt;&gt;&gt;&gt; 한 줄을 실행하면, 요청이 GPU로 넘어가 블록이 SM에 분배되고 워프 단위로 실행됩니다.</a:t>
+            </a:r>
+            <a:endParaRPr lang="en-US" sz="1450" dirty="0"/>
+          </a:p>
+        </p:txBody>
+      </p:sp>
+      <p:sp>
+        <p:nvSpPr>
+          <p:cNvPr id="5" name="Shape 3"/>
+          <p:cNvSpPr/>
+          <p:nvPr/>
+        </p:nvSpPr>
+        <p:spPr>
+          <a:xfrm>
+            <a:off x="548640" y="1874520"/>
+            <a:ext cx="7040880" cy="841248"/>
           </a:xfrm>
           <a:prstGeom prst="roundRect">
             <a:avLst>
-              <a:gd name="adj" fmla="val 1778"/>
+              <a:gd name="adj" fmla="val 8696"/>
+            </a:avLst>
+          </a:prstGeom>
+          <a:solidFill>
+            <a:srgbClr val="16242C"/>
+          </a:solidFill>
+          <a:ln w="19050">
+            <a:solidFill>
+              <a:srgbClr val="3FB8C4"/>
+            </a:solidFill>
+            <a:prstDash val="solid"/>
+          </a:ln>
+        </p:spPr>
+      </p:sp>
+      <p:sp>
+        <p:nvSpPr>
+          <p:cNvPr id="6" name="Text 4"/>
+          <p:cNvSpPr/>
+          <p:nvPr/>
+        </p:nvSpPr>
+        <p:spPr>
+          <a:xfrm>
+            <a:off x="804672" y="1984248"/>
+            <a:ext cx="6583680" cy="365760"/>
+          </a:xfrm>
+          <a:prstGeom prst="rect">
+            <a:avLst/>
+          </a:prstGeom>
+          <a:noFill/>
+          <a:ln/>
+        </p:spPr>
+        <p:txBody>
+          <a:bodyPr wrap="square" lIns="0" tIns="0" rIns="0" bIns="0" rtlCol="0" anchor="ctr"/>
+          <a:lstStyle/>
+          <a:p>
+            <a:pPr indent="0" marL="0">
+              <a:buNone/>
+            </a:pPr>
+            <a:r>
+              <a:rPr lang="en-US" sz="1500" b="1" dirty="0">
+                <a:solidFill>
+                  <a:srgbClr val="3FB8C4"/>
+                </a:solidFill>
+                <a:latin typeface="Malgun Gothic" pitchFamily="34" charset="0"/>
+                <a:ea typeface="Malgun Gothic" pitchFamily="34" charset="-122"/>
+                <a:cs typeface="Malgun Gothic" pitchFamily="34" charset="-120"/>
+              </a:rPr>
+              <a:t>① 호스트(CPU) — 커널 실행 요청</a:t>
+            </a:r>
+            <a:endParaRPr lang="en-US" sz="1500" dirty="0"/>
+          </a:p>
+        </p:txBody>
+      </p:sp>
+      <p:sp>
+        <p:nvSpPr>
+          <p:cNvPr id="7" name="Text 5"/>
+          <p:cNvSpPr/>
+          <p:nvPr/>
+        </p:nvSpPr>
+        <p:spPr>
+          <a:xfrm>
+            <a:off x="804672" y="2331720"/>
+            <a:ext cx="6583680" cy="292608"/>
+          </a:xfrm>
+          <a:prstGeom prst="rect">
+            <a:avLst/>
+          </a:prstGeom>
+          <a:noFill/>
+          <a:ln/>
+        </p:spPr>
+        <p:txBody>
+          <a:bodyPr wrap="square" lIns="0" tIns="0" rIns="0" bIns="0" rtlCol="0" anchor="ctr"/>
+          <a:lstStyle/>
+          <a:p>
+            <a:pPr indent="0" marL="0">
+              <a:buNone/>
+            </a:pPr>
+            <a:r>
+              <a:rPr lang="en-US" sz="1100" dirty="0">
+                <a:solidFill>
+                  <a:srgbClr val="9FB0C4"/>
+                </a:solidFill>
+                <a:latin typeface="Courier New" pitchFamily="34" charset="0"/>
+                <a:ea typeface="Courier New" pitchFamily="34" charset="-122"/>
+                <a:cs typeface="Courier New" pitchFamily="34" charset="-120"/>
+              </a:rPr>
+              <a:t>deviceWriteConstant&lt;&lt;&lt;1024, 512&gt;&gt;&gt;(...)</a:t>
+            </a:r>
+            <a:endParaRPr lang="en-US" sz="1100" dirty="0"/>
+          </a:p>
+        </p:txBody>
+      </p:sp>
+      <p:sp>
+        <p:nvSpPr>
+          <p:cNvPr id="8" name="Shape 6"/>
+          <p:cNvSpPr/>
+          <p:nvPr/>
+        </p:nvSpPr>
+        <p:spPr>
+          <a:xfrm>
+            <a:off x="4069080" y="2734056"/>
+            <a:ext cx="0" cy="146304"/>
+          </a:xfrm>
+          <a:prstGeom prst="line">
+            <a:avLst/>
+          </a:prstGeom>
+          <a:noFill/>
+          <a:ln w="25400">
+            <a:solidFill>
+              <a:srgbClr val="6B7D94"/>
+            </a:solidFill>
+            <a:prstDash val="solid"/>
+            <a:tailEnd type="triangle"/>
+          </a:ln>
+        </p:spPr>
+      </p:sp>
+      <p:sp>
+        <p:nvSpPr>
+          <p:cNvPr id="9" name="Shape 7"/>
+          <p:cNvSpPr/>
+          <p:nvPr/>
+        </p:nvSpPr>
+        <p:spPr>
+          <a:xfrm>
+            <a:off x="548640" y="2898648"/>
+            <a:ext cx="7040880" cy="841248"/>
+          </a:xfrm>
+          <a:prstGeom prst="roundRect">
+            <a:avLst>
+              <a:gd name="adj" fmla="val 8696"/>
+            </a:avLst>
+          </a:prstGeom>
+          <a:solidFill>
+            <a:srgbClr val="241A16"/>
+          </a:solidFill>
+          <a:ln w="19050">
+            <a:solidFill>
+              <a:srgbClr val="E8A33D"/>
+            </a:solidFill>
+            <a:prstDash val="solid"/>
+          </a:ln>
+        </p:spPr>
+      </p:sp>
+      <p:sp>
+        <p:nvSpPr>
+          <p:cNvPr id="10" name="Text 8"/>
+          <p:cNvSpPr/>
+          <p:nvPr/>
+        </p:nvSpPr>
+        <p:spPr>
+          <a:xfrm>
+            <a:off x="804672" y="3008376"/>
+            <a:ext cx="6583680" cy="365760"/>
+          </a:xfrm>
+          <a:prstGeom prst="rect">
+            <a:avLst/>
+          </a:prstGeom>
+          <a:noFill/>
+          <a:ln/>
+        </p:spPr>
+        <p:txBody>
+          <a:bodyPr wrap="square" lIns="0" tIns="0" rIns="0" bIns="0" rtlCol="0" anchor="ctr"/>
+          <a:lstStyle/>
+          <a:p>
+            <a:pPr indent="0" marL="0">
+              <a:buNone/>
+            </a:pPr>
+            <a:r>
+              <a:rPr lang="en-US" sz="1500" b="1" dirty="0">
+                <a:solidFill>
+                  <a:srgbClr val="E8A33D"/>
+                </a:solidFill>
+                <a:latin typeface="Malgun Gothic" pitchFamily="34" charset="0"/>
+                <a:ea typeface="Malgun Gothic" pitchFamily="34" charset="-122"/>
+                <a:cs typeface="Malgun Gothic" pitchFamily="34" charset="-120"/>
+              </a:rPr>
+              <a:t>② GPU 스케줄러 — 블록을 SM에 분배</a:t>
+            </a:r>
+            <a:endParaRPr lang="en-US" sz="1500" dirty="0"/>
+          </a:p>
+        </p:txBody>
+      </p:sp>
+      <p:sp>
+        <p:nvSpPr>
+          <p:cNvPr id="11" name="Text 9"/>
+          <p:cNvSpPr/>
+          <p:nvPr/>
+        </p:nvSpPr>
+        <p:spPr>
+          <a:xfrm>
+            <a:off x="804672" y="3355848"/>
+            <a:ext cx="6583680" cy="292608"/>
+          </a:xfrm>
+          <a:prstGeom prst="rect">
+            <a:avLst/>
+          </a:prstGeom>
+          <a:noFill/>
+          <a:ln/>
+        </p:spPr>
+        <p:txBody>
+          <a:bodyPr wrap="square" lIns="0" tIns="0" rIns="0" bIns="0" rtlCol="0" anchor="ctr"/>
+          <a:lstStyle/>
+          <a:p>
+            <a:pPr indent="0" marL="0">
+              <a:buNone/>
+            </a:pPr>
+            <a:r>
+              <a:rPr lang="en-US" sz="1100" dirty="0">
+                <a:solidFill>
+                  <a:srgbClr val="9FB0C4"/>
+                </a:solidFill>
+                <a:latin typeface="Courier New" pitchFamily="34" charset="0"/>
+                <a:ea typeface="Courier New" pitchFamily="34" charset="-122"/>
+                <a:cs typeface="Courier New" pitchFamily="34" charset="-120"/>
+              </a:rPr>
+              <a:t>블록 1024개 → 여러 SM에 나눠 배정</a:t>
+            </a:r>
+            <a:endParaRPr lang="en-US" sz="1100" dirty="0"/>
+          </a:p>
+        </p:txBody>
+      </p:sp>
+      <p:sp>
+        <p:nvSpPr>
+          <p:cNvPr id="12" name="Shape 10"/>
+          <p:cNvSpPr/>
+          <p:nvPr/>
+        </p:nvSpPr>
+        <p:spPr>
+          <a:xfrm>
+            <a:off x="4069080" y="3758184"/>
+            <a:ext cx="0" cy="146304"/>
+          </a:xfrm>
+          <a:prstGeom prst="line">
+            <a:avLst/>
+          </a:prstGeom>
+          <a:noFill/>
+          <a:ln w="25400">
+            <a:solidFill>
+              <a:srgbClr val="6B7D94"/>
+            </a:solidFill>
+            <a:prstDash val="solid"/>
+            <a:tailEnd type="triangle"/>
+          </a:ln>
+        </p:spPr>
+      </p:sp>
+      <p:sp>
+        <p:nvSpPr>
+          <p:cNvPr id="13" name="Shape 11"/>
+          <p:cNvSpPr/>
+          <p:nvPr/>
+        </p:nvSpPr>
+        <p:spPr>
+          <a:xfrm>
+            <a:off x="548640" y="3922776"/>
+            <a:ext cx="7040880" cy="841248"/>
+          </a:xfrm>
+          <a:prstGeom prst="roundRect">
+            <a:avLst>
+              <a:gd name="adj" fmla="val 8696"/>
+            </a:avLst>
+          </a:prstGeom>
+          <a:solidFill>
+            <a:srgbClr val="241A16"/>
+          </a:solidFill>
+          <a:ln w="19050">
+            <a:solidFill>
+              <a:srgbClr val="E8A33D"/>
+            </a:solidFill>
+            <a:prstDash val="solid"/>
+          </a:ln>
+        </p:spPr>
+      </p:sp>
+      <p:sp>
+        <p:nvSpPr>
+          <p:cNvPr id="14" name="Text 12"/>
+          <p:cNvSpPr/>
+          <p:nvPr/>
+        </p:nvSpPr>
+        <p:spPr>
+          <a:xfrm>
+            <a:off x="804672" y="4032504"/>
+            <a:ext cx="6583680" cy="365760"/>
+          </a:xfrm>
+          <a:prstGeom prst="rect">
+            <a:avLst/>
+          </a:prstGeom>
+          <a:noFill/>
+          <a:ln/>
+        </p:spPr>
+        <p:txBody>
+          <a:bodyPr wrap="square" lIns="0" tIns="0" rIns="0" bIns="0" rtlCol="0" anchor="ctr"/>
+          <a:lstStyle/>
+          <a:p>
+            <a:pPr indent="0" marL="0">
+              <a:buNone/>
+            </a:pPr>
+            <a:r>
+              <a:rPr lang="en-US" sz="1500" b="1" dirty="0">
+                <a:solidFill>
+                  <a:srgbClr val="E8A33D"/>
+                </a:solidFill>
+                <a:latin typeface="Malgun Gothic" pitchFamily="34" charset="0"/>
+                <a:ea typeface="Malgun Gothic" pitchFamily="34" charset="-122"/>
+                <a:cs typeface="Malgun Gothic" pitchFamily="34" charset="-120"/>
+              </a:rPr>
+              <a:t>③ 각 SM — 워프(32 스레드) 단위로 실행</a:t>
+            </a:r>
+            <a:endParaRPr lang="en-US" sz="1500" dirty="0"/>
+          </a:p>
+        </p:txBody>
+      </p:sp>
+      <p:sp>
+        <p:nvSpPr>
+          <p:cNvPr id="15" name="Text 13"/>
+          <p:cNvSpPr/>
+          <p:nvPr/>
+        </p:nvSpPr>
+        <p:spPr>
+          <a:xfrm>
+            <a:off x="804672" y="4379976"/>
+            <a:ext cx="6583680" cy="292608"/>
+          </a:xfrm>
+          <a:prstGeom prst="rect">
+            <a:avLst/>
+          </a:prstGeom>
+          <a:noFill/>
+          <a:ln/>
+        </p:spPr>
+        <p:txBody>
+          <a:bodyPr wrap="square" lIns="0" tIns="0" rIns="0" bIns="0" rtlCol="0" anchor="ctr"/>
+          <a:lstStyle/>
+          <a:p>
+            <a:pPr indent="0" marL="0">
+              <a:buNone/>
+            </a:pPr>
+            <a:r>
+              <a:rPr lang="en-US" sz="1100" dirty="0">
+                <a:solidFill>
+                  <a:srgbClr val="9FB0C4"/>
+                </a:solidFill>
+                <a:latin typeface="Courier New" pitchFamily="34" charset="0"/>
+                <a:ea typeface="Courier New" pitchFamily="34" charset="-122"/>
+                <a:cs typeface="Courier New" pitchFamily="34" charset="-120"/>
+              </a:rPr>
+              <a:t>블록 안 512 스레드가 실제 연산 수행</a:t>
+            </a:r>
+            <a:endParaRPr lang="en-US" sz="1100" dirty="0"/>
+          </a:p>
+        </p:txBody>
+      </p:sp>
+      <p:sp>
+        <p:nvSpPr>
+          <p:cNvPr id="16" name="Shape 14"/>
+          <p:cNvSpPr/>
+          <p:nvPr/>
+        </p:nvSpPr>
+        <p:spPr>
+          <a:xfrm>
+            <a:off x="4069080" y="4782312"/>
+            <a:ext cx="0" cy="146304"/>
+          </a:xfrm>
+          <a:prstGeom prst="line">
+            <a:avLst/>
+          </a:prstGeom>
+          <a:noFill/>
+          <a:ln w="25400">
+            <a:solidFill>
+              <a:srgbClr val="6B7D94"/>
+            </a:solidFill>
+            <a:prstDash val="solid"/>
+            <a:tailEnd type="triangle"/>
+          </a:ln>
+        </p:spPr>
+      </p:sp>
+      <p:sp>
+        <p:nvSpPr>
+          <p:cNvPr id="17" name="Shape 15"/>
+          <p:cNvSpPr/>
+          <p:nvPr/>
+        </p:nvSpPr>
+        <p:spPr>
+          <a:xfrm>
+            <a:off x="548640" y="4946904"/>
+            <a:ext cx="7040880" cy="841248"/>
+          </a:xfrm>
+          <a:prstGeom prst="roundRect">
+            <a:avLst>
+              <a:gd name="adj" fmla="val 8696"/>
+            </a:avLst>
+          </a:prstGeom>
+          <a:solidFill>
+            <a:srgbClr val="241A16"/>
+          </a:solidFill>
+          <a:ln w="19050">
+            <a:solidFill>
+              <a:srgbClr val="E8A33D"/>
+            </a:solidFill>
+            <a:prstDash val="solid"/>
+          </a:ln>
+        </p:spPr>
+      </p:sp>
+      <p:sp>
+        <p:nvSpPr>
+          <p:cNvPr id="18" name="Text 16"/>
+          <p:cNvSpPr/>
+          <p:nvPr/>
+        </p:nvSpPr>
+        <p:spPr>
+          <a:xfrm>
+            <a:off x="804672" y="5056632"/>
+            <a:ext cx="6583680" cy="365760"/>
+          </a:xfrm>
+          <a:prstGeom prst="rect">
+            <a:avLst/>
+          </a:prstGeom>
+          <a:noFill/>
+          <a:ln/>
+        </p:spPr>
+        <p:txBody>
+          <a:bodyPr wrap="square" lIns="0" tIns="0" rIns="0" bIns="0" rtlCol="0" anchor="ctr"/>
+          <a:lstStyle/>
+          <a:p>
+            <a:pPr indent="0" marL="0">
+              <a:buNone/>
+            </a:pPr>
+            <a:r>
+              <a:rPr lang="en-US" sz="1500" b="1" dirty="0">
+                <a:solidFill>
+                  <a:srgbClr val="E8A33D"/>
+                </a:solidFill>
+                <a:latin typeface="Malgun Gothic" pitchFamily="34" charset="0"/>
+                <a:ea typeface="Malgun Gothic" pitchFamily="34" charset="-122"/>
+                <a:cs typeface="Malgun Gothic" pitchFamily="34" charset="-120"/>
+              </a:rPr>
+              <a:t>④ 커널 완료 — 결과는 전역 메모리에</a:t>
+            </a:r>
+            <a:endParaRPr lang="en-US" sz="1500" dirty="0"/>
+          </a:p>
+        </p:txBody>
+      </p:sp>
+      <p:sp>
+        <p:nvSpPr>
+          <p:cNvPr id="19" name="Text 17"/>
+          <p:cNvSpPr/>
+          <p:nvPr/>
+        </p:nvSpPr>
+        <p:spPr>
+          <a:xfrm>
+            <a:off x="804672" y="5404104"/>
+            <a:ext cx="6583680" cy="292608"/>
+          </a:xfrm>
+          <a:prstGeom prst="rect">
+            <a:avLst/>
+          </a:prstGeom>
+          <a:noFill/>
+          <a:ln/>
+        </p:spPr>
+        <p:txBody>
+          <a:bodyPr wrap="square" lIns="0" tIns="0" rIns="0" bIns="0" rtlCol="0" anchor="ctr"/>
+          <a:lstStyle/>
+          <a:p>
+            <a:pPr indent="0" marL="0">
+              <a:buNone/>
+            </a:pPr>
+            <a:r>
+              <a:rPr lang="en-US" sz="1100" dirty="0">
+                <a:solidFill>
+                  <a:srgbClr val="9FB0C4"/>
+                </a:solidFill>
+                <a:latin typeface="Courier New" pitchFamily="34" charset="0"/>
+                <a:ea typeface="Courier New" pitchFamily="34" charset="-122"/>
+                <a:cs typeface="Courier New" pitchFamily="34" charset="-120"/>
+              </a:rPr>
+              <a:t>호스트는 SOFTWAIT로 완료를 기다림</a:t>
+            </a:r>
+            <a:endParaRPr lang="en-US" sz="1100" dirty="0"/>
+          </a:p>
+        </p:txBody>
+      </p:sp>
+      <p:sp>
+        <p:nvSpPr>
+          <p:cNvPr id="20" name="Text 18"/>
+          <p:cNvSpPr/>
+          <p:nvPr/>
+        </p:nvSpPr>
+        <p:spPr>
+          <a:xfrm>
+            <a:off x="7726680" y="2057400"/>
+            <a:ext cx="1371600" cy="365760"/>
+          </a:xfrm>
+          <a:prstGeom prst="rect">
+            <a:avLst/>
+          </a:prstGeom>
+          <a:noFill/>
+          <a:ln/>
+        </p:spPr>
+        <p:txBody>
+          <a:bodyPr wrap="square" lIns="0" tIns="0" rIns="0" bIns="0" rtlCol="0" anchor="ctr"/>
+          <a:lstStyle/>
+          <a:p>
+            <a:pPr indent="0" marL="0">
+              <a:buNone/>
+            </a:pPr>
+            <a:r>
+              <a:rPr lang="en-US" sz="1200" b="1" dirty="0">
+                <a:solidFill>
+                  <a:srgbClr val="3FB8C4"/>
+                </a:solidFill>
+                <a:latin typeface="Malgun Gothic" pitchFamily="34" charset="0"/>
+                <a:ea typeface="Malgun Gothic" pitchFamily="34" charset="-122"/>
+                <a:cs typeface="Malgun Gothic" pitchFamily="34" charset="-120"/>
+              </a:rPr>
+              <a:t>호스트</a:t>
+            </a:r>
+            <a:endParaRPr lang="en-US" sz="1200" dirty="0"/>
+          </a:p>
+        </p:txBody>
+      </p:sp>
+      <p:sp>
+        <p:nvSpPr>
+          <p:cNvPr id="21" name="Text 19"/>
+          <p:cNvSpPr/>
+          <p:nvPr/>
+        </p:nvSpPr>
+        <p:spPr>
+          <a:xfrm>
+            <a:off x="7726680" y="3108960"/>
+            <a:ext cx="1737360" cy="365760"/>
+          </a:xfrm>
+          <a:prstGeom prst="rect">
+            <a:avLst/>
+          </a:prstGeom>
+          <a:noFill/>
+          <a:ln/>
+        </p:spPr>
+        <p:txBody>
+          <a:bodyPr wrap="square" lIns="0" tIns="0" rIns="0" bIns="0" rtlCol="0" anchor="ctr"/>
+          <a:lstStyle/>
+          <a:p>
+            <a:pPr indent="0" marL="0">
+              <a:buNone/>
+            </a:pPr>
+            <a:r>
+              <a:rPr lang="en-US" sz="1200" b="1" dirty="0">
+                <a:solidFill>
+                  <a:srgbClr val="E8A33D"/>
+                </a:solidFill>
+                <a:latin typeface="Malgun Gothic" pitchFamily="34" charset="0"/>
+                <a:ea typeface="Malgun Gothic" pitchFamily="34" charset="-122"/>
+                <a:cs typeface="Malgun Gothic" pitchFamily="34" charset="-120"/>
+              </a:rPr>
+              <a:t>디바이스(GPU)</a:t>
+            </a:r>
+            <a:endParaRPr lang="en-US" sz="1200" dirty="0"/>
+          </a:p>
+        </p:txBody>
+      </p:sp>
+      <p:sp>
+        <p:nvSpPr>
+          <p:cNvPr id="22" name="Shape 20"/>
+          <p:cNvSpPr/>
+          <p:nvPr/>
+        </p:nvSpPr>
+        <p:spPr>
+          <a:xfrm>
+            <a:off x="9692640" y="1874520"/>
+            <a:ext cx="1920240" cy="3977640"/>
+          </a:xfrm>
+          <a:prstGeom prst="roundRect">
+            <a:avLst>
+              <a:gd name="adj" fmla="val 3810"/>
             </a:avLst>
           </a:prstGeom>
           <a:solidFill>
             <a:srgbClr val="18212E"/>
           </a:solidFill>
-          <a:ln/>
-        </p:spPr>
-      </p:sp>
-      <p:sp>
-        <p:nvSpPr>
-          <p:cNvPr id="5" name="Text 3"/>
-          <p:cNvSpPr/>
-          <p:nvPr/>
-        </p:nvSpPr>
-        <p:spPr>
-          <a:xfrm>
-            <a:off x="822960" y="1828800"/>
-            <a:ext cx="4800600" cy="457200"/>
+          <a:ln w="19050">
+            <a:solidFill>
+              <a:srgbClr val="E6604F"/>
+            </a:solidFill>
+            <a:prstDash val="solid"/>
+          </a:ln>
+        </p:spPr>
+      </p:sp>
+      <p:sp>
+        <p:nvSpPr>
+          <p:cNvPr id="23" name="Text 21"/>
+          <p:cNvSpPr/>
+          <p:nvPr/>
+        </p:nvSpPr>
+        <p:spPr>
+          <a:xfrm>
+            <a:off x="9921240" y="2057400"/>
+            <a:ext cx="1463040" cy="411480"/>
           </a:xfrm>
           <a:prstGeom prst="rect">
             <a:avLst/>
@@ -2194,30 +2897,30 @@
               <a:buNone/>
             </a:pPr>
             <a:r>
-              <a:rPr lang="en-US" sz="2000" b="1" dirty="0">
-                <a:solidFill>
-                  <a:srgbClr val="E8A33D"/>
+              <a:rPr lang="en-US" sz="1600" b="1" dirty="0">
+                <a:solidFill>
+                  <a:srgbClr val="E6604F"/>
                 </a:solidFill>
                 <a:latin typeface="Malgun Gothic" pitchFamily="34" charset="0"/>
                 <a:ea typeface="Malgun Gothic" pitchFamily="34" charset="-122"/>
                 <a:cs typeface="Malgun Gothic" pitchFamily="34" charset="-120"/>
               </a:rPr>
-              <a:t>기억할 것</a:t>
-            </a:r>
-            <a:endParaRPr lang="en-US" sz="2000" dirty="0"/>
-          </a:p>
-        </p:txBody>
-      </p:sp>
-      <p:sp>
-        <p:nvSpPr>
-          <p:cNvPr id="6" name="Text 4"/>
-          <p:cNvSpPr/>
-          <p:nvPr/>
-        </p:nvSpPr>
-        <p:spPr>
-          <a:xfrm>
-            <a:off x="822960" y="2423160"/>
-            <a:ext cx="4800600" cy="3108960"/>
+              <a:t>비동기(async)</a:t>
+            </a:r>
+            <a:endParaRPr lang="en-US" sz="1600" dirty="0"/>
+          </a:p>
+        </p:txBody>
+      </p:sp>
+      <p:sp>
+        <p:nvSpPr>
+          <p:cNvPr id="24" name="Text 22"/>
+          <p:cNvSpPr/>
+          <p:nvPr/>
+        </p:nvSpPr>
+        <p:spPr>
+          <a:xfrm>
+            <a:off x="9921240" y="2606040"/>
+            <a:ext cx="1463040" cy="3063240"/>
           </a:xfrm>
           <a:prstGeom prst="rect">
             <a:avLst/>
@@ -2229,18 +2932,17 @@
           <a:bodyPr wrap="square" lIns="0" tIns="0" rIns="0" bIns="0" rtlCol="0" anchor="t"/>
           <a:lstStyle/>
           <a:p>
-            <a:pPr marL="342900" indent="-342900">
+            <a:pPr indent="0" marL="0">
               <a:lnSpc>
-                <a:spcPct val="105000"/>
+                <a:spcPct val="115000"/>
               </a:lnSpc>
               <a:spcAft>
-                <a:spcPts val="1200"/>
+                <a:spcPts val="1000"/>
               </a:spcAft>
-              <a:buSzPct val="100000"/>
-              <a:buChar char="✓"/>
-            </a:pPr>
-            <a:r>
-              <a:rPr lang="en-US" sz="1600" dirty="0">
+              <a:buNone/>
+            </a:pPr>
+            <a:r>
+              <a:rPr lang="en-US" sz="1350" dirty="0">
                 <a:solidFill>
                   <a:srgbClr val="E7EDF5"/>
                 </a:solidFill>
@@ -2248,23 +2950,22 @@
                 <a:ea typeface="Malgun Gothic" pitchFamily="34" charset="-122"/>
                 <a:cs typeface="Malgun Gothic" pitchFamily="34" charset="-120"/>
               </a:rPr>
-              <a:t>커널 = __global__, 반환형 void</a:t>
-            </a:r>
-            <a:endParaRPr lang="en-US" sz="1600" dirty="0"/>
-          </a:p>
-          <a:p>
-            <a:pPr marL="342900" indent="-342900">
+              <a:t>호스트는 ① 요청 후 곧바로 다음 코드로 갑니다.</a:t>
+            </a:r>
+            <a:endParaRPr lang="en-US" sz="1350" dirty="0"/>
+          </a:p>
+          <a:p>
+            <a:pPr indent="0" marL="0">
               <a:lnSpc>
-                <a:spcPct val="105000"/>
+                <a:spcPct val="115000"/>
               </a:lnSpc>
               <a:spcAft>
-                <a:spcPts val="1200"/>
+                <a:spcPts val="1000"/>
               </a:spcAft>
-              <a:buSzPct val="100000"/>
-              <a:buChar char="✓"/>
-            </a:pPr>
-            <a:r>
-              <a:rPr lang="en-US" sz="1600" dirty="0">
+              <a:buNone/>
+            </a:pPr>
+            <a:r>
+              <a:rPr lang="en-US" sz="1350" dirty="0">
                 <a:solidFill>
                   <a:srgbClr val="E7EDF5"/>
                 </a:solidFill>
@@ -2272,236 +2973,29 @@
                 <a:ea typeface="Malgun Gothic" pitchFamily="34" charset="-122"/>
                 <a:cs typeface="Malgun Gothic" pitchFamily="34" charset="-120"/>
               </a:rPr>
-              <a:t>&lt;&lt;&lt;1024, 512&gt;&gt;&gt; = 블록수, 블록당 스레드수</a:t>
-            </a:r>
-            <a:endParaRPr lang="en-US" sz="1600" dirty="0"/>
-          </a:p>
-          <a:p>
-            <a:pPr marL="342900" indent="-342900">
+              <a:t>결과가 필요하면 SOFTWAIT로 GPU 완료를 기다립니다.</a:t>
+            </a:r>
+            <a:endParaRPr lang="en-US" sz="1350" dirty="0"/>
+          </a:p>
+          <a:p>
+            <a:pPr indent="0" marL="0">
               <a:lnSpc>
-                <a:spcPct val="105000"/>
+                <a:spcPct val="115000"/>
               </a:lnSpc>
-              <a:spcAft>
-                <a:spcPts val="1200"/>
-              </a:spcAft>
-              <a:buSzPct val="100000"/>
-              <a:buChar char="✓"/>
-            </a:pPr>
-            <a:r>
-              <a:rPr lang="en-US" sz="1600" dirty="0">
-                <a:solidFill>
-                  <a:srgbClr val="E7EDF5"/>
+              <a:buNone/>
+            </a:pPr>
+            <a:r>
+              <a:rPr lang="en-US" sz="1350" i="1" dirty="0">
+                <a:solidFill>
+                  <a:srgbClr val="9FB0C4"/>
                 </a:solidFill>
                 <a:latin typeface="Malgun Gothic" pitchFamily="34" charset="0"/>
                 <a:ea typeface="Malgun Gothic" pitchFamily="34" charset="-122"/>
                 <a:cs typeface="Malgun Gothic" pitchFamily="34" charset="-120"/>
               </a:rPr>
-              <a:t>THREAD_ADDRESS로 겹치지 않는 자기 word 계산</a:t>
-            </a:r>
-            <a:endParaRPr lang="en-US" sz="1600" dirty="0"/>
-          </a:p>
-          <a:p>
-            <a:pPr marL="342900" indent="-342900">
-              <a:lnSpc>
-                <a:spcPct val="105000"/>
-              </a:lnSpc>
-              <a:spcAft>
-                <a:spcPts val="1200"/>
-              </a:spcAft>
-              <a:buSzPct val="100000"/>
-              <a:buChar char="✓"/>
-            </a:pPr>
-            <a:r>
-              <a:rPr lang="en-US" sz="1600" dirty="0">
-                <a:solidFill>
-                  <a:srgbClr val="E7EDF5"/>
-                </a:solidFill>
-                <a:latin typeface="Malgun Gothic" pitchFamily="34" charset="0"/>
-                <a:ea typeface="Malgun Gothic" pitchFamily="34" charset="-122"/>
-                <a:cs typeface="Malgun Gothic" pitchFamily="34" charset="-120"/>
-              </a:rPr>
-              <a:t>이웃 스레드 = 이웃 주소 → coalescing</a:t>
-            </a:r>
-            <a:endParaRPr lang="en-US" sz="1600" dirty="0"/>
-          </a:p>
-        </p:txBody>
-      </p:sp>
-      <p:sp>
-        <p:nvSpPr>
-          <p:cNvPr id="7" name="Shape 5"/>
-          <p:cNvSpPr/>
-          <p:nvPr/>
-        </p:nvSpPr>
-        <p:spPr>
-          <a:xfrm>
-            <a:off x="6263640" y="1600200"/>
-            <a:ext cx="5349240" cy="4114800"/>
-          </a:xfrm>
-          <a:prstGeom prst="roundRect">
-            <a:avLst>
-              <a:gd name="adj" fmla="val 1778"/>
-            </a:avLst>
-          </a:prstGeom>
-          <a:solidFill>
-            <a:srgbClr val="18212E"/>
-          </a:solidFill>
-          <a:ln/>
-        </p:spPr>
-      </p:sp>
-      <p:sp>
-        <p:nvSpPr>
-          <p:cNvPr id="8" name="Text 6"/>
-          <p:cNvSpPr/>
-          <p:nvPr/>
-        </p:nvSpPr>
-        <p:spPr>
-          <a:xfrm>
-            <a:off x="6537960" y="1828800"/>
-            <a:ext cx="4800600" cy="457200"/>
-          </a:xfrm>
-          <a:prstGeom prst="rect">
-            <a:avLst/>
-          </a:prstGeom>
-          <a:noFill/>
-          <a:ln/>
-        </p:spPr>
-        <p:txBody>
-          <a:bodyPr wrap="square" lIns="0" tIns="0" rIns="0" bIns="0" rtlCol="0" anchor="ctr"/>
-          <a:lstStyle/>
-          <a:p>
-            <a:pPr indent="0" marL="0">
-              <a:buNone/>
-            </a:pPr>
-            <a:r>
-              <a:rPr lang="en-US" sz="2000" b="1" dirty="0">
-                <a:solidFill>
-                  <a:srgbClr val="E6604F"/>
-                </a:solidFill>
-                <a:latin typeface="Malgun Gothic" pitchFamily="34" charset="0"/>
-                <a:ea typeface="Malgun Gothic" pitchFamily="34" charset="-122"/>
-                <a:cs typeface="Malgun Gothic" pitchFamily="34" charset="-120"/>
-              </a:rPr>
-              <a:t>입문자 함정</a:t>
-            </a:r>
-            <a:endParaRPr lang="en-US" sz="2000" dirty="0"/>
-          </a:p>
-        </p:txBody>
-      </p:sp>
-      <p:sp>
-        <p:nvSpPr>
-          <p:cNvPr id="9" name="Text 7"/>
-          <p:cNvSpPr/>
-          <p:nvPr/>
-        </p:nvSpPr>
-        <p:spPr>
-          <a:xfrm>
-            <a:off x="6537960" y="2423160"/>
-            <a:ext cx="4800600" cy="3108960"/>
-          </a:xfrm>
-          <a:prstGeom prst="rect">
-            <a:avLst/>
-          </a:prstGeom>
-          <a:noFill/>
-          <a:ln/>
-        </p:spPr>
-        <p:txBody>
-          <a:bodyPr wrap="square" lIns="0" tIns="0" rIns="0" bIns="0" rtlCol="0" anchor="t"/>
-          <a:lstStyle/>
-          <a:p>
-            <a:pPr marL="342900" indent="-342900">
-              <a:lnSpc>
-                <a:spcPct val="105000"/>
-              </a:lnSpc>
-              <a:spcAft>
-                <a:spcPts val="1200"/>
-              </a:spcAft>
-              <a:buSzPct val="100000"/>
-              <a:buChar char="✗"/>
-            </a:pPr>
-            <a:r>
-              <a:rPr lang="en-US" sz="1550" dirty="0">
-                <a:solidFill>
-                  <a:srgbClr val="E7EDF5"/>
-                </a:solidFill>
-                <a:latin typeface="Malgun Gothic" pitchFamily="34" charset="0"/>
-                <a:ea typeface="Malgun Gothic" pitchFamily="34" charset="-122"/>
-                <a:cs typeface="Malgun Gothic" pitchFamily="34" charset="-120"/>
-              </a:rPr>
-              <a:t>커널을 일반 함수처럼 () 로 호출 → &lt;&lt;&lt;&gt;&gt;&gt; 필수</a:t>
-            </a:r>
-            <a:endParaRPr lang="en-US" sz="1550" dirty="0"/>
-          </a:p>
-          <a:p>
-            <a:pPr marL="342900" indent="-342900">
-              <a:lnSpc>
-                <a:spcPct val="105000"/>
-              </a:lnSpc>
-              <a:spcAft>
-                <a:spcPts val="1200"/>
-              </a:spcAft>
-              <a:buSzPct val="100000"/>
-              <a:buChar char="✗"/>
-            </a:pPr>
-            <a:r>
-              <a:rPr lang="en-US" sz="1550" dirty="0">
-                <a:solidFill>
-                  <a:srgbClr val="E7EDF5"/>
-                </a:solidFill>
-                <a:latin typeface="Malgun Gothic" pitchFamily="34" charset="0"/>
-                <a:ea typeface="Malgun Gothic" pitchFamily="34" charset="-122"/>
-                <a:cs typeface="Malgun Gothic" pitchFamily="34" charset="-120"/>
-              </a:rPr>
-              <a:t>커널에서 값을 return 하려 함 → void, 결과는 메모리로</a:t>
-            </a:r>
-            <a:endParaRPr lang="en-US" sz="1550" dirty="0"/>
-          </a:p>
-          <a:p>
-            <a:pPr marL="342900" indent="-342900">
-              <a:lnSpc>
-                <a:spcPct val="105000"/>
-              </a:lnSpc>
-              <a:spcAft>
-                <a:spcPts val="1200"/>
-              </a:spcAft>
-              <a:buSzPct val="100000"/>
-              <a:buChar char="✗"/>
-            </a:pPr>
-            <a:r>
-              <a:rPr lang="en-US" sz="1550" dirty="0">
-                <a:solidFill>
-                  <a:srgbClr val="E7EDF5"/>
-                </a:solidFill>
-                <a:latin typeface="Malgun Gothic" pitchFamily="34" charset="0"/>
-                <a:ea typeface="Malgun Gothic" pitchFamily="34" charset="-122"/>
-                <a:cs typeface="Malgun Gothic" pitchFamily="34" charset="-120"/>
-              </a:rPr>
-              <a:t>호스트 포인터를 커널에 그대로 전달 → 디바이스 포인터여야</a:t>
-            </a:r>
-            <a:endParaRPr lang="en-US" sz="1550" dirty="0"/>
-          </a:p>
-          <a:p>
-            <a:pPr marL="342900" indent="-342900">
-              <a:lnSpc>
-                <a:spcPct val="105000"/>
-              </a:lnSpc>
-              <a:spcAft>
-                <a:spcPts val="1200"/>
-              </a:spcAft>
-              <a:buSzPct val="100000"/>
-              <a:buChar char="✗"/>
-            </a:pPr>
-            <a:r>
-              <a:rPr lang="en-US" sz="1550" dirty="0">
-                <a:solidFill>
-                  <a:srgbClr val="E7EDF5"/>
-                </a:solidFill>
-                <a:latin typeface="Malgun Gothic" pitchFamily="34" charset="0"/>
-                <a:ea typeface="Malgun Gothic" pitchFamily="34" charset="-122"/>
-                <a:cs typeface="Malgun Gothic" pitchFamily="34" charset="-120"/>
-              </a:rPr>
-              <a:t>blockDim을 스레드마다 다르다고 착각 → 모두 같은 값</a:t>
-            </a:r>
-            <a:endParaRPr lang="en-US" sz="1550" dirty="0"/>
+              <a:t>→ 이 비동기 특성은 세션 2(검증)·세션 4(타이밍)에서 자세히.</a:t>
+            </a:r>
+            <a:endParaRPr lang="en-US" sz="1350" dirty="0"/>
           </a:p>
         </p:txBody>
       </p:sp>
@@ -2516,6 +3010,478 @@
 <file path=ppt/slides/slide11.xml><?xml version="1.0" encoding="utf-8"?>
 <p:sld xmlns:a="http://schemas.openxmlformats.org/drawingml/2006/main" xmlns:r="http://schemas.openxmlformats.org/officeDocument/2006/relationships" xmlns:p="http://schemas.openxmlformats.org/presentationml/2006/main">
   <p:cSld name="Slide 11">
+    <p:bg>
+      <p:bgPr>
+        <a:solidFill>
+          <a:srgbClr val="101722"/>
+        </a:solidFill>
+      </p:bgPr>
+    </p:bg>
+    <p:spTree>
+      <p:nvGrpSpPr>
+        <p:cNvPr id="1" name=""/>
+        <p:cNvGrpSpPr/>
+        <p:nvPr/>
+      </p:nvGrpSpPr>
+      <p:grpSpPr>
+        <a:xfrm>
+          <a:off x="0" y="0"/>
+          <a:ext cx="0" cy="0"/>
+          <a:chOff x="0" y="0"/>
+          <a:chExt cx="0" cy="0"/>
+        </a:xfrm>
+      </p:grpSpPr>
+      <p:sp>
+        <p:nvSpPr>
+          <p:cNvPr id="2" name="Text 0"/>
+          <p:cNvSpPr/>
+          <p:nvPr/>
+        </p:nvSpPr>
+        <p:spPr>
+          <a:xfrm>
+            <a:off x="548640" y="411480"/>
+            <a:ext cx="658368" cy="658368"/>
+          </a:xfrm>
+          <a:prstGeom prst="roundRect">
+            <a:avLst>
+              <a:gd name="adj" fmla="val 13889"/>
+            </a:avLst>
+          </a:prstGeom>
+          <a:solidFill>
+            <a:srgbClr val="E8A33D"/>
+          </a:solidFill>
+          <a:ln/>
+        </p:spPr>
+        <p:txBody>
+          <a:bodyPr wrap="square" rtlCol="0" anchor="ctr"/>
+          <a:lstStyle/>
+          <a:p>
+            <a:pPr algn="ctr" indent="0" marL="0">
+              <a:buNone/>
+            </a:pPr>
+            <a:r>
+              <a:rPr lang="en-US" sz="2200" b="1" dirty="0">
+                <a:solidFill>
+                  <a:srgbClr val="101722"/>
+                </a:solidFill>
+                <a:latin typeface="Courier New" pitchFamily="34" charset="0"/>
+                <a:ea typeface="Courier New" pitchFamily="34" charset="-122"/>
+                <a:cs typeface="Courier New" pitchFamily="34" charset="-120"/>
+              </a:rPr>
+              <a:t>9</a:t>
+            </a:r>
+            <a:endParaRPr lang="en-US" sz="2200" dirty="0"/>
+          </a:p>
+        </p:txBody>
+      </p:sp>
+      <p:sp>
+        <p:nvSpPr>
+          <p:cNvPr id="3" name="Text 1"/>
+          <p:cNvSpPr/>
+          <p:nvPr/>
+        </p:nvSpPr>
+        <p:spPr>
+          <a:xfrm>
+            <a:off x="1371600" y="384048"/>
+            <a:ext cx="10241280" cy="713232"/>
+          </a:xfrm>
+          <a:prstGeom prst="rect">
+            <a:avLst/>
+          </a:prstGeom>
+          <a:noFill/>
+          <a:ln/>
+        </p:spPr>
+        <p:txBody>
+          <a:bodyPr wrap="square" lIns="0" tIns="0" rIns="0" bIns="0" rtlCol="0" anchor="ctr"/>
+          <a:lstStyle/>
+          <a:p>
+            <a:pPr algn="l" indent="0" marL="0">
+              <a:buNone/>
+            </a:pPr>
+            <a:r>
+              <a:rPr lang="en-US" sz="2900" b="1" dirty="0">
+                <a:solidFill>
+                  <a:srgbClr val="E7EDF5"/>
+                </a:solidFill>
+                <a:latin typeface="Malgun Gothic" pitchFamily="34" charset="0"/>
+                <a:ea typeface="Malgun Gothic" pitchFamily="34" charset="-122"/>
+                <a:cs typeface="Malgun Gothic" pitchFamily="34" charset="-120"/>
+              </a:rPr>
+              <a:t>핵심 정리 &amp; 자주 하는 실수</a:t>
+            </a:r>
+            <a:endParaRPr lang="en-US" sz="2900" dirty="0"/>
+          </a:p>
+        </p:txBody>
+      </p:sp>
+      <p:sp>
+        <p:nvSpPr>
+          <p:cNvPr id="4" name="Shape 2"/>
+          <p:cNvSpPr/>
+          <p:nvPr/>
+        </p:nvSpPr>
+        <p:spPr>
+          <a:xfrm>
+            <a:off x="548640" y="1600200"/>
+            <a:ext cx="5349240" cy="4114800"/>
+          </a:xfrm>
+          <a:prstGeom prst="roundRect">
+            <a:avLst>
+              <a:gd name="adj" fmla="val 1778"/>
+            </a:avLst>
+          </a:prstGeom>
+          <a:solidFill>
+            <a:srgbClr val="18212E"/>
+          </a:solidFill>
+          <a:ln/>
+        </p:spPr>
+      </p:sp>
+      <p:sp>
+        <p:nvSpPr>
+          <p:cNvPr id="5" name="Text 3"/>
+          <p:cNvSpPr/>
+          <p:nvPr/>
+        </p:nvSpPr>
+        <p:spPr>
+          <a:xfrm>
+            <a:off x="822960" y="1828800"/>
+            <a:ext cx="4800600" cy="457200"/>
+          </a:xfrm>
+          <a:prstGeom prst="rect">
+            <a:avLst/>
+          </a:prstGeom>
+          <a:noFill/>
+          <a:ln/>
+        </p:spPr>
+        <p:txBody>
+          <a:bodyPr wrap="square" lIns="0" tIns="0" rIns="0" bIns="0" rtlCol="0" anchor="ctr"/>
+          <a:lstStyle/>
+          <a:p>
+            <a:pPr indent="0" marL="0">
+              <a:buNone/>
+            </a:pPr>
+            <a:r>
+              <a:rPr lang="en-US" sz="2000" b="1" dirty="0">
+                <a:solidFill>
+                  <a:srgbClr val="E8A33D"/>
+                </a:solidFill>
+                <a:latin typeface="Malgun Gothic" pitchFamily="34" charset="0"/>
+                <a:ea typeface="Malgun Gothic" pitchFamily="34" charset="-122"/>
+                <a:cs typeface="Malgun Gothic" pitchFamily="34" charset="-120"/>
+              </a:rPr>
+              <a:t>기억할 것</a:t>
+            </a:r>
+            <a:endParaRPr lang="en-US" sz="2000" dirty="0"/>
+          </a:p>
+        </p:txBody>
+      </p:sp>
+      <p:sp>
+        <p:nvSpPr>
+          <p:cNvPr id="6" name="Text 4"/>
+          <p:cNvSpPr/>
+          <p:nvPr/>
+        </p:nvSpPr>
+        <p:spPr>
+          <a:xfrm>
+            <a:off x="822960" y="2423160"/>
+            <a:ext cx="4800600" cy="3108960"/>
+          </a:xfrm>
+          <a:prstGeom prst="rect">
+            <a:avLst/>
+          </a:prstGeom>
+          <a:noFill/>
+          <a:ln/>
+        </p:spPr>
+        <p:txBody>
+          <a:bodyPr wrap="square" lIns="0" tIns="0" rIns="0" bIns="0" rtlCol="0" anchor="t"/>
+          <a:lstStyle/>
+          <a:p>
+            <a:pPr marL="342900" indent="-342900">
+              <a:lnSpc>
+                <a:spcPct val="105000"/>
+              </a:lnSpc>
+              <a:spcAft>
+                <a:spcPts val="1200"/>
+              </a:spcAft>
+              <a:buSzPct val="100000"/>
+              <a:buChar char="✓"/>
+            </a:pPr>
+            <a:r>
+              <a:rPr lang="en-US" sz="1600" dirty="0">
+                <a:solidFill>
+                  <a:srgbClr val="E7EDF5"/>
+                </a:solidFill>
+                <a:latin typeface="Malgun Gothic" pitchFamily="34" charset="0"/>
+                <a:ea typeface="Malgun Gothic" pitchFamily="34" charset="-122"/>
+                <a:cs typeface="Malgun Gothic" pitchFamily="34" charset="-120"/>
+              </a:rPr>
+              <a:t>커널 = __global__, 반환형 void</a:t>
+            </a:r>
+            <a:endParaRPr lang="en-US" sz="1600" dirty="0"/>
+          </a:p>
+          <a:p>
+            <a:pPr marL="342900" indent="-342900">
+              <a:lnSpc>
+                <a:spcPct val="105000"/>
+              </a:lnSpc>
+              <a:spcAft>
+                <a:spcPts val="1200"/>
+              </a:spcAft>
+              <a:buSzPct val="100000"/>
+              <a:buChar char="✓"/>
+            </a:pPr>
+            <a:r>
+              <a:rPr lang="en-US" sz="1600" dirty="0">
+                <a:solidFill>
+                  <a:srgbClr val="E7EDF5"/>
+                </a:solidFill>
+                <a:latin typeface="Malgun Gothic" pitchFamily="34" charset="0"/>
+                <a:ea typeface="Malgun Gothic" pitchFamily="34" charset="-122"/>
+                <a:cs typeface="Malgun Gothic" pitchFamily="34" charset="-120"/>
+              </a:rPr>
+              <a:t>&lt;&lt;&lt;1024, 512&gt;&gt;&gt; = 블록수, 블록당 스레드수</a:t>
+            </a:r>
+            <a:endParaRPr lang="en-US" sz="1600" dirty="0"/>
+          </a:p>
+          <a:p>
+            <a:pPr marL="342900" indent="-342900">
+              <a:lnSpc>
+                <a:spcPct val="105000"/>
+              </a:lnSpc>
+              <a:spcAft>
+                <a:spcPts val="1200"/>
+              </a:spcAft>
+              <a:buSzPct val="100000"/>
+              <a:buChar char="✓"/>
+            </a:pPr>
+            <a:r>
+              <a:rPr lang="en-US" sz="1600" dirty="0">
+                <a:solidFill>
+                  <a:srgbClr val="E7EDF5"/>
+                </a:solidFill>
+                <a:latin typeface="Malgun Gothic" pitchFamily="34" charset="0"/>
+                <a:ea typeface="Malgun Gothic" pitchFamily="34" charset="-122"/>
+                <a:cs typeface="Malgun Gothic" pitchFamily="34" charset="-120"/>
+              </a:rPr>
+              <a:t>THREAD_ADDRESS로 겹치지 않는 자기 word 계산</a:t>
+            </a:r>
+            <a:endParaRPr lang="en-US" sz="1600" dirty="0"/>
+          </a:p>
+          <a:p>
+            <a:pPr marL="342900" indent="-342900">
+              <a:lnSpc>
+                <a:spcPct val="105000"/>
+              </a:lnSpc>
+              <a:spcAft>
+                <a:spcPts val="1200"/>
+              </a:spcAft>
+              <a:buSzPct val="100000"/>
+              <a:buChar char="✓"/>
+            </a:pPr>
+            <a:r>
+              <a:rPr lang="en-US" sz="1600" dirty="0">
+                <a:solidFill>
+                  <a:srgbClr val="E7EDF5"/>
+                </a:solidFill>
+                <a:latin typeface="Malgun Gothic" pitchFamily="34" charset="0"/>
+                <a:ea typeface="Malgun Gothic" pitchFamily="34" charset="-122"/>
+                <a:cs typeface="Malgun Gothic" pitchFamily="34" charset="-120"/>
+              </a:rPr>
+              <a:t>이웃 스레드 = 이웃 주소 → coalescing</a:t>
+            </a:r>
+            <a:endParaRPr lang="en-US" sz="1600" dirty="0"/>
+          </a:p>
+        </p:txBody>
+      </p:sp>
+      <p:sp>
+        <p:nvSpPr>
+          <p:cNvPr id="7" name="Shape 5"/>
+          <p:cNvSpPr/>
+          <p:nvPr/>
+        </p:nvSpPr>
+        <p:spPr>
+          <a:xfrm>
+            <a:off x="6263640" y="1600200"/>
+            <a:ext cx="5349240" cy="4114800"/>
+          </a:xfrm>
+          <a:prstGeom prst="roundRect">
+            <a:avLst>
+              <a:gd name="adj" fmla="val 1778"/>
+            </a:avLst>
+          </a:prstGeom>
+          <a:solidFill>
+            <a:srgbClr val="18212E"/>
+          </a:solidFill>
+          <a:ln/>
+        </p:spPr>
+      </p:sp>
+      <p:sp>
+        <p:nvSpPr>
+          <p:cNvPr id="8" name="Text 6"/>
+          <p:cNvSpPr/>
+          <p:nvPr/>
+        </p:nvSpPr>
+        <p:spPr>
+          <a:xfrm>
+            <a:off x="6537960" y="1828800"/>
+            <a:ext cx="4800600" cy="457200"/>
+          </a:xfrm>
+          <a:prstGeom prst="rect">
+            <a:avLst/>
+          </a:prstGeom>
+          <a:noFill/>
+          <a:ln/>
+        </p:spPr>
+        <p:txBody>
+          <a:bodyPr wrap="square" lIns="0" tIns="0" rIns="0" bIns="0" rtlCol="0" anchor="ctr"/>
+          <a:lstStyle/>
+          <a:p>
+            <a:pPr indent="0" marL="0">
+              <a:buNone/>
+            </a:pPr>
+            <a:r>
+              <a:rPr lang="en-US" sz="2000" b="1" dirty="0">
+                <a:solidFill>
+                  <a:srgbClr val="E6604F"/>
+                </a:solidFill>
+                <a:latin typeface="Malgun Gothic" pitchFamily="34" charset="0"/>
+                <a:ea typeface="Malgun Gothic" pitchFamily="34" charset="-122"/>
+                <a:cs typeface="Malgun Gothic" pitchFamily="34" charset="-120"/>
+              </a:rPr>
+              <a:t>입문자 함정</a:t>
+            </a:r>
+            <a:endParaRPr lang="en-US" sz="2000" dirty="0"/>
+          </a:p>
+        </p:txBody>
+      </p:sp>
+      <p:sp>
+        <p:nvSpPr>
+          <p:cNvPr id="9" name="Text 7"/>
+          <p:cNvSpPr/>
+          <p:nvPr/>
+        </p:nvSpPr>
+        <p:spPr>
+          <a:xfrm>
+            <a:off x="6537960" y="2423160"/>
+            <a:ext cx="4800600" cy="3108960"/>
+          </a:xfrm>
+          <a:prstGeom prst="rect">
+            <a:avLst/>
+          </a:prstGeom>
+          <a:noFill/>
+          <a:ln/>
+        </p:spPr>
+        <p:txBody>
+          <a:bodyPr wrap="square" lIns="0" tIns="0" rIns="0" bIns="0" rtlCol="0" anchor="t"/>
+          <a:lstStyle/>
+          <a:p>
+            <a:pPr marL="342900" indent="-342900">
+              <a:lnSpc>
+                <a:spcPct val="105000"/>
+              </a:lnSpc>
+              <a:spcAft>
+                <a:spcPts val="1200"/>
+              </a:spcAft>
+              <a:buSzPct val="100000"/>
+              <a:buChar char="✗"/>
+            </a:pPr>
+            <a:r>
+              <a:rPr lang="en-US" sz="1550" dirty="0">
+                <a:solidFill>
+                  <a:srgbClr val="E7EDF5"/>
+                </a:solidFill>
+                <a:latin typeface="Malgun Gothic" pitchFamily="34" charset="0"/>
+                <a:ea typeface="Malgun Gothic" pitchFamily="34" charset="-122"/>
+                <a:cs typeface="Malgun Gothic" pitchFamily="34" charset="-120"/>
+              </a:rPr>
+              <a:t>커널을 일반 함수처럼 () 로 호출 → &lt;&lt;&lt;&gt;&gt;&gt; 필수</a:t>
+            </a:r>
+            <a:endParaRPr lang="en-US" sz="1550" dirty="0"/>
+          </a:p>
+          <a:p>
+            <a:pPr marL="342900" indent="-342900">
+              <a:lnSpc>
+                <a:spcPct val="105000"/>
+              </a:lnSpc>
+              <a:spcAft>
+                <a:spcPts val="1200"/>
+              </a:spcAft>
+              <a:buSzPct val="100000"/>
+              <a:buChar char="✗"/>
+            </a:pPr>
+            <a:r>
+              <a:rPr lang="en-US" sz="1550" dirty="0">
+                <a:solidFill>
+                  <a:srgbClr val="E7EDF5"/>
+                </a:solidFill>
+                <a:latin typeface="Malgun Gothic" pitchFamily="34" charset="0"/>
+                <a:ea typeface="Malgun Gothic" pitchFamily="34" charset="-122"/>
+                <a:cs typeface="Malgun Gothic" pitchFamily="34" charset="-120"/>
+              </a:rPr>
+              <a:t>커널에서 값을 return 하려 함 → void, 결과는 메모리로</a:t>
+            </a:r>
+            <a:endParaRPr lang="en-US" sz="1550" dirty="0"/>
+          </a:p>
+          <a:p>
+            <a:pPr marL="342900" indent="-342900">
+              <a:lnSpc>
+                <a:spcPct val="105000"/>
+              </a:lnSpc>
+              <a:spcAft>
+                <a:spcPts val="1200"/>
+              </a:spcAft>
+              <a:buSzPct val="100000"/>
+              <a:buChar char="✗"/>
+            </a:pPr>
+            <a:r>
+              <a:rPr lang="en-US" sz="1550" dirty="0">
+                <a:solidFill>
+                  <a:srgbClr val="E7EDF5"/>
+                </a:solidFill>
+                <a:latin typeface="Malgun Gothic" pitchFamily="34" charset="0"/>
+                <a:ea typeface="Malgun Gothic" pitchFamily="34" charset="-122"/>
+                <a:cs typeface="Malgun Gothic" pitchFamily="34" charset="-120"/>
+              </a:rPr>
+              <a:t>호스트 포인터를 커널에 그대로 전달 → 디바이스 포인터여야</a:t>
+            </a:r>
+            <a:endParaRPr lang="en-US" sz="1550" dirty="0"/>
+          </a:p>
+          <a:p>
+            <a:pPr marL="342900" indent="-342900">
+              <a:lnSpc>
+                <a:spcPct val="105000"/>
+              </a:lnSpc>
+              <a:spcAft>
+                <a:spcPts val="1200"/>
+              </a:spcAft>
+              <a:buSzPct val="100000"/>
+              <a:buChar char="✗"/>
+            </a:pPr>
+            <a:r>
+              <a:rPr lang="en-US" sz="1550" dirty="0">
+                <a:solidFill>
+                  <a:srgbClr val="E7EDF5"/>
+                </a:solidFill>
+                <a:latin typeface="Malgun Gothic" pitchFamily="34" charset="0"/>
+                <a:ea typeface="Malgun Gothic" pitchFamily="34" charset="-122"/>
+                <a:cs typeface="Malgun Gothic" pitchFamily="34" charset="-120"/>
+              </a:rPr>
+              <a:t>blockDim을 스레드마다 다르다고 착각 → 모두 같은 값</a:t>
+            </a:r>
+            <a:endParaRPr lang="en-US" sz="1550" dirty="0"/>
+          </a:p>
+        </p:txBody>
+      </p:sp>
+    </p:spTree>
+  </p:cSld>
+  <p:clrMapOvr>
+    <a:masterClrMapping/>
+  </p:clrMapOvr>
+</p:sld>
+</file>
+
+<file path=ppt/slides/slide12.xml><?xml version="1.0" encoding="utf-8"?>
+<p:sld xmlns:a="http://schemas.openxmlformats.org/drawingml/2006/main" xmlns:r="http://schemas.openxmlformats.org/officeDocument/2006/relationships" xmlns:p="http://schemas.openxmlformats.org/presentationml/2006/main">
+  <p:cSld name="Slide 12">
     <p:bg>
       <p:bgPr>
         <a:solidFill>

</xml_diff>